<commit_message>
Update footer link to emcdigitalsolutions.github.io
Co-Authored-By: Claude Opus 4.6 <noreply@anthropic.com>
</commit_message>
<xml_diff>
--- a/Proposta_Refactoring_Fratelli_Di_Rosa.pptx
+++ b/Proposta_Refactoring_Fratelli_Di_Rosa.pptx
@@ -5,20 +5,20 @@
     <p:sldMasterId id="2147483648" r:id="rId1"/>
   </p:sldMasterIdLst>
   <p:sldIdLst>
-    <p:sldId id="256" r:id="rId7"/>
-    <p:sldId id="257" r:id="rId8"/>
-    <p:sldId id="258" r:id="rId9"/>
-    <p:sldId id="259" r:id="rId10"/>
-    <p:sldId id="260" r:id="rId11"/>
-    <p:sldId id="261" r:id="rId12"/>
-    <p:sldId id="262" r:id="rId13"/>
-    <p:sldId id="263" r:id="rId14"/>
-    <p:sldId id="264" r:id="rId15"/>
-    <p:sldId id="265" r:id="rId16"/>
-    <p:sldId id="266" r:id="rId17"/>
-    <p:sldId id="267" r:id="rId18"/>
+    <p:sldId id="256" r:id="rId2"/>
+    <p:sldId id="257" r:id="rId3"/>
+    <p:sldId id="258" r:id="rId4"/>
+    <p:sldId id="259" r:id="rId5"/>
+    <p:sldId id="260" r:id="rId6"/>
+    <p:sldId id="261" r:id="rId7"/>
+    <p:sldId id="262" r:id="rId8"/>
+    <p:sldId id="263" r:id="rId9"/>
+    <p:sldId id="264" r:id="rId10"/>
+    <p:sldId id="265" r:id="rId11"/>
+    <p:sldId id="266" r:id="rId12"/>
+    <p:sldId id="267" r:id="rId13"/>
   </p:sldIdLst>
-  <p:sldSz cx="12191695" cy="6858000" type="screen4x3"/>
+  <p:sldSz cx="12192000" cy="6858000"/>
   <p:notesSz cx="6858000" cy="9144000"/>
   <p:defaultTextStyle>
     <a:defPPr>
@@ -115,6 +115,22 @@
       </a:defRPr>
     </a:lvl9pPr>
   </p:defaultTextStyle>
+  <p:extLst>
+    <p:ext uri="{EFAFB233-063F-42B5-8137-9DF3F51BA10A}">
+      <p15:sldGuideLst xmlns:p15="http://schemas.microsoft.com/office/powerpoint/2012/main">
+        <p15:guide id="1" orient="horz" pos="2160">
+          <p15:clr>
+            <a:srgbClr val="A4A3A4"/>
+          </p15:clr>
+        </p15:guide>
+        <p15:guide id="2" pos="2880">
+          <p15:clr>
+            <a:srgbClr val="A4A3A4"/>
+          </p15:clr>
+        </p15:guide>
+      </p15:sldGuideLst>
+    </p:ext>
+  </p:extLst>
 </p:presentation>
 </file>
 
@@ -299,7 +315,7 @@
           <a:p>
             <a:fld id="{5BCAD085-E8A6-8845-BD4E-CB4CCA059FC4}" type="datetimeFigureOut">
               <a:rPr lang="en-US" smtClean="0"/>
-              <a:t>1/27/13</a:t>
+              <a:t>3/13/2026</a:t>
             </a:fld>
             <a:endParaRPr lang="en-US"/>
           </a:p>
@@ -341,7 +357,7 @@
           <a:p>
             <a:fld id="{C1FF6DA9-008F-8B48-92A6-B652298478BF}" type="slidenum">
               <a:rPr lang="en-US" smtClean="0"/>
-              <a:t>‹#›</a:t>
+              <a:t>‹N›</a:t>
             </a:fld>
             <a:endParaRPr lang="en-US"/>
           </a:p>
@@ -469,7 +485,7 @@
           <a:p>
             <a:fld id="{5BCAD085-E8A6-8845-BD4E-CB4CCA059FC4}" type="datetimeFigureOut">
               <a:rPr lang="en-US" smtClean="0"/>
-              <a:t>1/27/13</a:t>
+              <a:t>3/13/2026</a:t>
             </a:fld>
             <a:endParaRPr lang="en-US"/>
           </a:p>
@@ -511,7 +527,7 @@
           <a:p>
             <a:fld id="{C1FF6DA9-008F-8B48-92A6-B652298478BF}" type="slidenum">
               <a:rPr lang="en-US" smtClean="0"/>
-              <a:t>‹#›</a:t>
+              <a:t>‹N›</a:t>
             </a:fld>
             <a:endParaRPr lang="en-US"/>
           </a:p>
@@ -649,7 +665,7 @@
           <a:p>
             <a:fld id="{5BCAD085-E8A6-8845-BD4E-CB4CCA059FC4}" type="datetimeFigureOut">
               <a:rPr lang="en-US" smtClean="0"/>
-              <a:t>1/27/13</a:t>
+              <a:t>3/13/2026</a:t>
             </a:fld>
             <a:endParaRPr lang="en-US"/>
           </a:p>
@@ -691,7 +707,7 @@
           <a:p>
             <a:fld id="{C1FF6DA9-008F-8B48-92A6-B652298478BF}" type="slidenum">
               <a:rPr lang="en-US" smtClean="0"/>
-              <a:t>‹#›</a:t>
+              <a:t>‹N›</a:t>
             </a:fld>
             <a:endParaRPr lang="en-US"/>
           </a:p>
@@ -819,7 +835,7 @@
           <a:p>
             <a:fld id="{5BCAD085-E8A6-8845-BD4E-CB4CCA059FC4}" type="datetimeFigureOut">
               <a:rPr lang="en-US" smtClean="0"/>
-              <a:t>1/27/13</a:t>
+              <a:t>3/13/2026</a:t>
             </a:fld>
             <a:endParaRPr lang="en-US"/>
           </a:p>
@@ -861,7 +877,7 @@
           <a:p>
             <a:fld id="{C1FF6DA9-008F-8B48-92A6-B652298478BF}" type="slidenum">
               <a:rPr lang="en-US" smtClean="0"/>
-              <a:t>‹#›</a:t>
+              <a:t>‹N›</a:t>
             </a:fld>
             <a:endParaRPr lang="en-US"/>
           </a:p>
@@ -1065,7 +1081,7 @@
           <a:p>
             <a:fld id="{5BCAD085-E8A6-8845-BD4E-CB4CCA059FC4}" type="datetimeFigureOut">
               <a:rPr lang="en-US" smtClean="0"/>
-              <a:t>1/27/13</a:t>
+              <a:t>3/13/2026</a:t>
             </a:fld>
             <a:endParaRPr lang="en-US"/>
           </a:p>
@@ -1107,7 +1123,7 @@
           <a:p>
             <a:fld id="{C1FF6DA9-008F-8B48-92A6-B652298478BF}" type="slidenum">
               <a:rPr lang="en-US" smtClean="0"/>
-              <a:t>‹#›</a:t>
+              <a:t>‹N›</a:t>
             </a:fld>
             <a:endParaRPr lang="en-US"/>
           </a:p>
@@ -1353,7 +1369,7 @@
           <a:p>
             <a:fld id="{5BCAD085-E8A6-8845-BD4E-CB4CCA059FC4}" type="datetimeFigureOut">
               <a:rPr lang="en-US" smtClean="0"/>
-              <a:t>1/27/13</a:t>
+              <a:t>3/13/2026</a:t>
             </a:fld>
             <a:endParaRPr lang="en-US"/>
           </a:p>
@@ -1395,7 +1411,7 @@
           <a:p>
             <a:fld id="{C1FF6DA9-008F-8B48-92A6-B652298478BF}" type="slidenum">
               <a:rPr lang="en-US" smtClean="0"/>
-              <a:t>‹#›</a:t>
+              <a:t>‹N›</a:t>
             </a:fld>
             <a:endParaRPr lang="en-US"/>
           </a:p>
@@ -1775,7 +1791,7 @@
           <a:p>
             <a:fld id="{5BCAD085-E8A6-8845-BD4E-CB4CCA059FC4}" type="datetimeFigureOut">
               <a:rPr lang="en-US" smtClean="0"/>
-              <a:t>1/27/13</a:t>
+              <a:t>3/13/2026</a:t>
             </a:fld>
             <a:endParaRPr lang="en-US"/>
           </a:p>
@@ -1817,7 +1833,7 @@
           <a:p>
             <a:fld id="{C1FF6DA9-008F-8B48-92A6-B652298478BF}" type="slidenum">
               <a:rPr lang="en-US" smtClean="0"/>
-              <a:t>‹#›</a:t>
+              <a:t>‹N›</a:t>
             </a:fld>
             <a:endParaRPr lang="en-US"/>
           </a:p>
@@ -1893,7 +1909,7 @@
           <a:p>
             <a:fld id="{5BCAD085-E8A6-8845-BD4E-CB4CCA059FC4}" type="datetimeFigureOut">
               <a:rPr lang="en-US" smtClean="0"/>
-              <a:t>1/27/13</a:t>
+              <a:t>3/13/2026</a:t>
             </a:fld>
             <a:endParaRPr lang="en-US"/>
           </a:p>
@@ -1935,7 +1951,7 @@
           <a:p>
             <a:fld id="{C1FF6DA9-008F-8B48-92A6-B652298478BF}" type="slidenum">
               <a:rPr lang="en-US" smtClean="0"/>
-              <a:t>‹#›</a:t>
+              <a:t>‹N›</a:t>
             </a:fld>
             <a:endParaRPr lang="en-US"/>
           </a:p>
@@ -1988,7 +2004,7 @@
           <a:p>
             <a:fld id="{5BCAD085-E8A6-8845-BD4E-CB4CCA059FC4}" type="datetimeFigureOut">
               <a:rPr lang="en-US" smtClean="0"/>
-              <a:t>1/27/13</a:t>
+              <a:t>3/13/2026</a:t>
             </a:fld>
             <a:endParaRPr lang="en-US"/>
           </a:p>
@@ -2030,7 +2046,7 @@
           <a:p>
             <a:fld id="{C1FF6DA9-008F-8B48-92A6-B652298478BF}" type="slidenum">
               <a:rPr lang="en-US" smtClean="0"/>
-              <a:t>‹#›</a:t>
+              <a:t>‹N›</a:t>
             </a:fld>
             <a:endParaRPr lang="en-US"/>
           </a:p>
@@ -2265,7 +2281,7 @@
           <a:p>
             <a:fld id="{5BCAD085-E8A6-8845-BD4E-CB4CCA059FC4}" type="datetimeFigureOut">
               <a:rPr lang="en-US" smtClean="0"/>
-              <a:t>1/27/13</a:t>
+              <a:t>3/13/2026</a:t>
             </a:fld>
             <a:endParaRPr lang="en-US"/>
           </a:p>
@@ -2307,7 +2323,7 @@
           <a:p>
             <a:fld id="{C1FF6DA9-008F-8B48-92A6-B652298478BF}" type="slidenum">
               <a:rPr lang="en-US" smtClean="0"/>
-              <a:t>‹#›</a:t>
+              <a:t>‹N›</a:t>
             </a:fld>
             <a:endParaRPr lang="en-US"/>
           </a:p>
@@ -2518,7 +2534,7 @@
           <a:p>
             <a:fld id="{5BCAD085-E8A6-8845-BD4E-CB4CCA059FC4}" type="datetimeFigureOut">
               <a:rPr lang="en-US" smtClean="0"/>
-              <a:t>1/27/13</a:t>
+              <a:t>3/13/2026</a:t>
             </a:fld>
             <a:endParaRPr lang="en-US"/>
           </a:p>
@@ -2560,7 +2576,7 @@
           <a:p>
             <a:fld id="{C1FF6DA9-008F-8B48-92A6-B652298478BF}" type="slidenum">
               <a:rPr lang="en-US" smtClean="0"/>
-              <a:t>‹#›</a:t>
+              <a:t>‹N›</a:t>
             </a:fld>
             <a:endParaRPr lang="en-US"/>
           </a:p>
@@ -2731,7 +2747,7 @@
           <a:p>
             <a:fld id="{5BCAD085-E8A6-8845-BD4E-CB4CCA059FC4}" type="datetimeFigureOut">
               <a:rPr lang="en-US" smtClean="0"/>
-              <a:t>1/27/13</a:t>
+              <a:t>3/13/2026</a:t>
             </a:fld>
             <a:endParaRPr lang="en-US"/>
           </a:p>
@@ -2809,7 +2825,7 @@
           <a:p>
             <a:fld id="{C1FF6DA9-008F-8B48-92A6-B652298478BF}" type="slidenum">
               <a:rPr lang="en-US" smtClean="0"/>
-              <a:t>‹#›</a:t>
+              <a:t>‹N›</a:t>
             </a:fld>
             <a:endParaRPr lang="en-US"/>
           </a:p>
@@ -3090,7 +3106,7 @@
 </file>
 
 <file path=ppt/slides/slide1.xml><?xml version="1.0" encoding="utf-8"?>
-<p:sld xmlns:a="http://schemas.openxmlformats.org/drawingml/2006/main" xmlns:p="http://schemas.openxmlformats.org/presentationml/2006/main" xmlns:r="http://schemas.openxmlformats.org/officeDocument/2006/relationships">
+<p:sld xmlns:a="http://schemas.openxmlformats.org/drawingml/2006/main" xmlns:r="http://schemas.openxmlformats.org/officeDocument/2006/relationships" xmlns:p="http://schemas.openxmlformats.org/presentationml/2006/main">
   <p:cSld>
     <p:bg>
       <p:bgPr>
@@ -3106,7 +3122,14 @@
         <p:cNvGrpSpPr/>
         <p:nvPr/>
       </p:nvGrpSpPr>
-      <p:grpSpPr/>
+      <p:grpSpPr>
+        <a:xfrm>
+          <a:off x="0" y="0"/>
+          <a:ext cx="0" cy="0"/>
+          <a:chOff x="0" y="0"/>
+          <a:chExt cx="0" cy="0"/>
+        </a:xfrm>
+      </p:grpSpPr>
       <p:sp>
         <p:nvSpPr>
           <p:cNvPr id="2" name="Rectangle 1"/>
@@ -3147,6 +3170,7 @@
           <a:lstStyle/>
           <a:p>
             <a:pPr algn="ctr"/>
+            <a:endParaRPr/>
           </a:p>
         </p:txBody>
       </p:sp>
@@ -3188,7 +3212,7 @@
           </a:fontRef>
         </p:style>
         <p:txBody>
-          <a:bodyPr rtlCol="0" anchor="ctr" wrap="square"/>
+          <a:bodyPr wrap="square" rtlCol="0" anchor="ctr"/>
           <a:lstStyle/>
           <a:p>
             <a:pPr algn="ctr">
@@ -3320,6 +3344,7 @@
           <a:lstStyle/>
           <a:p>
             <a:pPr algn="ctr"/>
+            <a:endParaRPr/>
           </a:p>
         </p:txBody>
       </p:sp>
@@ -3471,6 +3496,7 @@
           <a:lstStyle/>
           <a:p>
             <a:pPr algn="ctr"/>
+            <a:endParaRPr/>
           </a:p>
         </p:txBody>
       </p:sp>
@@ -3483,7 +3509,7 @@
 </file>
 
 <file path=ppt/slides/slide10.xml><?xml version="1.0" encoding="utf-8"?>
-<p:sld xmlns:a="http://schemas.openxmlformats.org/drawingml/2006/main" xmlns:p="http://schemas.openxmlformats.org/presentationml/2006/main" xmlns:r="http://schemas.openxmlformats.org/officeDocument/2006/relationships">
+<p:sld xmlns:a="http://schemas.openxmlformats.org/drawingml/2006/main" xmlns:r="http://schemas.openxmlformats.org/officeDocument/2006/relationships" xmlns:p="http://schemas.openxmlformats.org/presentationml/2006/main">
   <p:cSld>
     <p:bg>
       <p:bgPr>
@@ -3499,7 +3525,14 @@
         <p:cNvGrpSpPr/>
         <p:nvPr/>
       </p:nvGrpSpPr>
-      <p:grpSpPr/>
+      <p:grpSpPr>
+        <a:xfrm>
+          <a:off x="0" y="0"/>
+          <a:ext cx="0" cy="0"/>
+          <a:chOff x="0" y="0"/>
+          <a:chExt cx="0" cy="0"/>
+        </a:xfrm>
+      </p:grpSpPr>
       <p:sp>
         <p:nvSpPr>
           <p:cNvPr id="2" name="TextBox 1"/>
@@ -3508,7 +3541,7 @@
         </p:nvSpPr>
         <p:spPr>
           <a:xfrm>
-            <a:off x="731520" y="365760"/>
+            <a:off x="594360" y="223545"/>
             <a:ext cx="5486400" cy="548640"/>
           </a:xfrm>
           <a:prstGeom prst="rect">
@@ -3531,6 +3564,7 @@
               </a:defRPr>
             </a:pPr>
             <a:r>
+              <a:rPr dirty="0"/>
               <a:t>PREVENTIVO ECONOMICO</a:t>
             </a:r>
           </a:p>
@@ -3544,7 +3578,7 @@
         </p:nvSpPr>
         <p:spPr>
           <a:xfrm>
-            <a:off x="731520" y="822960"/>
+            <a:off x="731520" y="640080"/>
             <a:ext cx="1828800" cy="38100"/>
           </a:xfrm>
           <a:prstGeom prst="rect">
@@ -3576,6 +3610,7 @@
           <a:lstStyle/>
           <a:p>
             <a:pPr algn="ctr"/>
+            <a:endParaRPr/>
           </a:p>
         </p:txBody>
       </p:sp>
@@ -3587,7 +3622,7 @@
         </p:nvSpPr>
         <p:spPr>
           <a:xfrm>
-            <a:off x="731520" y="1097280"/>
+            <a:off x="914400" y="607593"/>
             <a:ext cx="10515600" cy="548640"/>
           </a:xfrm>
           <a:prstGeom prst="rect">
@@ -3610,7 +3645,36 @@
               </a:defRPr>
             </a:pPr>
             <a:r>
-              <a:t>Investimento per il refactoring del vostro sito web</a:t>
+              <a:rPr dirty="0" err="1"/>
+              <a:t>Investimento</a:t>
+            </a:r>
+            <a:r>
+              <a:rPr dirty="0"/>
+              <a:t> per </a:t>
+            </a:r>
+            <a:r>
+              <a:rPr dirty="0" err="1"/>
+              <a:t>il</a:t>
+            </a:r>
+            <a:r>
+              <a:rPr dirty="0"/>
+              <a:t> refactoring del </a:t>
+            </a:r>
+            <a:r>
+              <a:rPr dirty="0" err="1"/>
+              <a:t>vostro</a:t>
+            </a:r>
+            <a:r>
+              <a:rPr dirty="0"/>
+              <a:t> </a:t>
+            </a:r>
+            <a:r>
+              <a:rPr dirty="0" err="1"/>
+              <a:t>sito</a:t>
+            </a:r>
+            <a:r>
+              <a:rPr dirty="0"/>
+              <a:t> web</a:t>
             </a:r>
           </a:p>
         </p:txBody>
@@ -3623,7 +3687,7 @@
         </p:nvSpPr>
         <p:spPr>
           <a:xfrm>
-            <a:off x="731520" y="1920240"/>
+            <a:off x="731520" y="1211097"/>
             <a:ext cx="8229600" cy="502920"/>
           </a:xfrm>
           <a:prstGeom prst="rect">
@@ -3655,6 +3719,7 @@
           <a:lstStyle/>
           <a:p>
             <a:pPr algn="ctr"/>
+            <a:endParaRPr/>
           </a:p>
         </p:txBody>
       </p:sp>
@@ -3666,7 +3731,7 @@
         </p:nvSpPr>
         <p:spPr>
           <a:xfrm>
-            <a:off x="914400" y="1965960"/>
+            <a:off x="914400" y="1256817"/>
             <a:ext cx="6400800" cy="411480"/>
           </a:xfrm>
           <a:prstGeom prst="rect">
@@ -3702,7 +3767,7 @@
         </p:nvSpPr>
         <p:spPr>
           <a:xfrm>
-            <a:off x="8961120" y="1920240"/>
+            <a:off x="8961120" y="1211097"/>
             <a:ext cx="2468880" cy="502920"/>
           </a:xfrm>
           <a:prstGeom prst="rect">
@@ -3734,6 +3799,7 @@
           <a:lstStyle/>
           <a:p>
             <a:pPr algn="ctr"/>
+            <a:endParaRPr/>
           </a:p>
         </p:txBody>
       </p:sp>
@@ -3745,7 +3811,7 @@
         </p:nvSpPr>
         <p:spPr>
           <a:xfrm>
-            <a:off x="8961120" y="1965960"/>
+            <a:off x="8961120" y="1256817"/>
             <a:ext cx="2468880" cy="411480"/>
           </a:xfrm>
           <a:prstGeom prst="rect">
@@ -3781,7 +3847,7 @@
         </p:nvSpPr>
         <p:spPr>
           <a:xfrm>
-            <a:off x="731520" y="2468880"/>
+            <a:off x="731520" y="1759737"/>
             <a:ext cx="10698480" cy="338328"/>
           </a:xfrm>
           <a:prstGeom prst="rect">
@@ -3813,6 +3879,7 @@
           <a:lstStyle/>
           <a:p>
             <a:pPr algn="ctr"/>
+            <a:endParaRPr/>
           </a:p>
         </p:txBody>
       </p:sp>
@@ -3824,7 +3891,7 @@
         </p:nvSpPr>
         <p:spPr>
           <a:xfrm>
-            <a:off x="914400" y="2478024"/>
+            <a:off x="914400" y="1768881"/>
             <a:ext cx="7772400" cy="301752"/>
           </a:xfrm>
           <a:prstGeom prst="rect">
@@ -3860,7 +3927,7 @@
         </p:nvSpPr>
         <p:spPr>
           <a:xfrm>
-            <a:off x="8961120" y="2478024"/>
+            <a:off x="8961120" y="1768881"/>
             <a:ext cx="2468880" cy="301752"/>
           </a:xfrm>
           <a:prstGeom prst="rect">
@@ -3896,7 +3963,7 @@
         </p:nvSpPr>
         <p:spPr>
           <a:xfrm>
-            <a:off x="731520" y="2825496"/>
+            <a:off x="731520" y="2116353"/>
             <a:ext cx="10698480" cy="338328"/>
           </a:xfrm>
           <a:prstGeom prst="rect">
@@ -3928,6 +3995,7 @@
           <a:lstStyle/>
           <a:p>
             <a:pPr algn="ctr"/>
+            <a:endParaRPr/>
           </a:p>
         </p:txBody>
       </p:sp>
@@ -3939,7 +4007,7 @@
         </p:nvSpPr>
         <p:spPr>
           <a:xfrm>
-            <a:off x="914400" y="2834640"/>
+            <a:off x="914400" y="2125497"/>
             <a:ext cx="7772400" cy="301752"/>
           </a:xfrm>
           <a:prstGeom prst="rect">
@@ -3975,7 +4043,7 @@
         </p:nvSpPr>
         <p:spPr>
           <a:xfrm>
-            <a:off x="8961120" y="2834640"/>
+            <a:off x="8961120" y="2125497"/>
             <a:ext cx="2468880" cy="301752"/>
           </a:xfrm>
           <a:prstGeom prst="rect">
@@ -4011,7 +4079,7 @@
         </p:nvSpPr>
         <p:spPr>
           <a:xfrm>
-            <a:off x="731520" y="3182112"/>
+            <a:off x="731520" y="2472969"/>
             <a:ext cx="10698480" cy="338328"/>
           </a:xfrm>
           <a:prstGeom prst="rect">
@@ -4043,6 +4111,7 @@
           <a:lstStyle/>
           <a:p>
             <a:pPr algn="ctr"/>
+            <a:endParaRPr/>
           </a:p>
         </p:txBody>
       </p:sp>
@@ -4054,7 +4123,7 @@
         </p:nvSpPr>
         <p:spPr>
           <a:xfrm>
-            <a:off x="914400" y="3191256"/>
+            <a:off x="914400" y="2482113"/>
             <a:ext cx="7772400" cy="301752"/>
           </a:xfrm>
           <a:prstGeom prst="rect">
@@ -4090,7 +4159,7 @@
         </p:nvSpPr>
         <p:spPr>
           <a:xfrm>
-            <a:off x="8961120" y="3191256"/>
+            <a:off x="8961120" y="2482113"/>
             <a:ext cx="2468880" cy="301752"/>
           </a:xfrm>
           <a:prstGeom prst="rect">
@@ -4126,7 +4195,7 @@
         </p:nvSpPr>
         <p:spPr>
           <a:xfrm>
-            <a:off x="731520" y="3538728"/>
+            <a:off x="731520" y="2829585"/>
             <a:ext cx="10698480" cy="338328"/>
           </a:xfrm>
           <a:prstGeom prst="rect">
@@ -4158,6 +4227,7 @@
           <a:lstStyle/>
           <a:p>
             <a:pPr algn="ctr"/>
+            <a:endParaRPr/>
           </a:p>
         </p:txBody>
       </p:sp>
@@ -4169,7 +4239,7 @@
         </p:nvSpPr>
         <p:spPr>
           <a:xfrm>
-            <a:off x="914400" y="3547872"/>
+            <a:off x="914400" y="2838729"/>
             <a:ext cx="7772400" cy="301752"/>
           </a:xfrm>
           <a:prstGeom prst="rect">
@@ -4205,7 +4275,7 @@
         </p:nvSpPr>
         <p:spPr>
           <a:xfrm>
-            <a:off x="8961120" y="3547872"/>
+            <a:off x="8961120" y="2838729"/>
             <a:ext cx="2468880" cy="301752"/>
           </a:xfrm>
           <a:prstGeom prst="rect">
@@ -4241,7 +4311,7 @@
         </p:nvSpPr>
         <p:spPr>
           <a:xfrm>
-            <a:off x="731520" y="3895344"/>
+            <a:off x="731520" y="3186201"/>
             <a:ext cx="10698480" cy="338328"/>
           </a:xfrm>
           <a:prstGeom prst="rect">
@@ -4273,6 +4343,7 @@
           <a:lstStyle/>
           <a:p>
             <a:pPr algn="ctr"/>
+            <a:endParaRPr/>
           </a:p>
         </p:txBody>
       </p:sp>
@@ -4284,7 +4355,7 @@
         </p:nvSpPr>
         <p:spPr>
           <a:xfrm>
-            <a:off x="914400" y="3904488"/>
+            <a:off x="914400" y="3195345"/>
             <a:ext cx="7772400" cy="301752"/>
           </a:xfrm>
           <a:prstGeom prst="rect">
@@ -4320,7 +4391,7 @@
         </p:nvSpPr>
         <p:spPr>
           <a:xfrm>
-            <a:off x="8961120" y="3904488"/>
+            <a:off x="8961120" y="3195345"/>
             <a:ext cx="2468880" cy="301752"/>
           </a:xfrm>
           <a:prstGeom prst="rect">
@@ -4356,7 +4427,7 @@
         </p:nvSpPr>
         <p:spPr>
           <a:xfrm>
-            <a:off x="731520" y="4251960"/>
+            <a:off x="731520" y="3542817"/>
             <a:ext cx="10698480" cy="338328"/>
           </a:xfrm>
           <a:prstGeom prst="rect">
@@ -4388,6 +4459,7 @@
           <a:lstStyle/>
           <a:p>
             <a:pPr algn="ctr"/>
+            <a:endParaRPr/>
           </a:p>
         </p:txBody>
       </p:sp>
@@ -4399,7 +4471,7 @@
         </p:nvSpPr>
         <p:spPr>
           <a:xfrm>
-            <a:off x="914400" y="4261104"/>
+            <a:off x="914400" y="3551961"/>
             <a:ext cx="7772400" cy="301752"/>
           </a:xfrm>
           <a:prstGeom prst="rect">
@@ -4435,7 +4507,7 @@
         </p:nvSpPr>
         <p:spPr>
           <a:xfrm>
-            <a:off x="8961120" y="4261104"/>
+            <a:off x="8961120" y="3551961"/>
             <a:ext cx="2468880" cy="301752"/>
           </a:xfrm>
           <a:prstGeom prst="rect">
@@ -4471,7 +4543,7 @@
         </p:nvSpPr>
         <p:spPr>
           <a:xfrm>
-            <a:off x="731520" y="4608576"/>
+            <a:off x="731520" y="3899433"/>
             <a:ext cx="10698480" cy="338328"/>
           </a:xfrm>
           <a:prstGeom prst="rect">
@@ -4503,6 +4575,7 @@
           <a:lstStyle/>
           <a:p>
             <a:pPr algn="ctr"/>
+            <a:endParaRPr/>
           </a:p>
         </p:txBody>
       </p:sp>
@@ -4514,7 +4587,7 @@
         </p:nvSpPr>
         <p:spPr>
           <a:xfrm>
-            <a:off x="914400" y="4617720"/>
+            <a:off x="914400" y="3908577"/>
             <a:ext cx="7772400" cy="301752"/>
           </a:xfrm>
           <a:prstGeom prst="rect">
@@ -4550,7 +4623,7 @@
         </p:nvSpPr>
         <p:spPr>
           <a:xfrm>
-            <a:off x="8961120" y="4617720"/>
+            <a:off x="8961120" y="3908577"/>
             <a:ext cx="2468880" cy="301752"/>
           </a:xfrm>
           <a:prstGeom prst="rect">
@@ -4586,7 +4659,7 @@
         </p:nvSpPr>
         <p:spPr>
           <a:xfrm>
-            <a:off x="731520" y="4965192"/>
+            <a:off x="731520" y="4256049"/>
             <a:ext cx="10698480" cy="338328"/>
           </a:xfrm>
           <a:prstGeom prst="rect">
@@ -4618,6 +4691,7 @@
           <a:lstStyle/>
           <a:p>
             <a:pPr algn="ctr"/>
+            <a:endParaRPr/>
           </a:p>
         </p:txBody>
       </p:sp>
@@ -4629,7 +4703,7 @@
         </p:nvSpPr>
         <p:spPr>
           <a:xfrm>
-            <a:off x="914400" y="4974336"/>
+            <a:off x="914400" y="4265193"/>
             <a:ext cx="7772400" cy="301752"/>
           </a:xfrm>
           <a:prstGeom prst="rect">
@@ -4665,7 +4739,7 @@
         </p:nvSpPr>
         <p:spPr>
           <a:xfrm>
-            <a:off x="8961120" y="4974336"/>
+            <a:off x="8961120" y="4265193"/>
             <a:ext cx="2468880" cy="301752"/>
           </a:xfrm>
           <a:prstGeom prst="rect">
@@ -4701,7 +4775,7 @@
         </p:nvSpPr>
         <p:spPr>
           <a:xfrm>
-            <a:off x="731520" y="5321808"/>
+            <a:off x="731520" y="4612665"/>
             <a:ext cx="10698480" cy="338328"/>
           </a:xfrm>
           <a:prstGeom prst="rect">
@@ -4733,6 +4807,7 @@
           <a:lstStyle/>
           <a:p>
             <a:pPr algn="ctr"/>
+            <a:endParaRPr/>
           </a:p>
         </p:txBody>
       </p:sp>
@@ -4744,7 +4819,7 @@
         </p:nvSpPr>
         <p:spPr>
           <a:xfrm>
-            <a:off x="914400" y="5330952"/>
+            <a:off x="914400" y="4621809"/>
             <a:ext cx="7772400" cy="301752"/>
           </a:xfrm>
           <a:prstGeom prst="rect">
@@ -4780,7 +4855,7 @@
         </p:nvSpPr>
         <p:spPr>
           <a:xfrm>
-            <a:off x="8961120" y="5330952"/>
+            <a:off x="8961120" y="4621809"/>
             <a:ext cx="2468880" cy="301752"/>
           </a:xfrm>
           <a:prstGeom prst="rect">
@@ -4816,7 +4891,7 @@
         </p:nvSpPr>
         <p:spPr>
           <a:xfrm>
-            <a:off x="731520" y="5678424"/>
+            <a:off x="731520" y="4969281"/>
             <a:ext cx="10698480" cy="338328"/>
           </a:xfrm>
           <a:prstGeom prst="rect">
@@ -4848,6 +4923,7 @@
           <a:lstStyle/>
           <a:p>
             <a:pPr algn="ctr"/>
+            <a:endParaRPr/>
           </a:p>
         </p:txBody>
       </p:sp>
@@ -4859,7 +4935,7 @@
         </p:nvSpPr>
         <p:spPr>
           <a:xfrm>
-            <a:off x="914400" y="5687568"/>
+            <a:off x="914400" y="4978425"/>
             <a:ext cx="7772400" cy="301752"/>
           </a:xfrm>
           <a:prstGeom prst="rect">
@@ -4895,7 +4971,7 @@
         </p:nvSpPr>
         <p:spPr>
           <a:xfrm>
-            <a:off x="8961120" y="5687568"/>
+            <a:off x="8961120" y="4978425"/>
             <a:ext cx="2468880" cy="301752"/>
           </a:xfrm>
           <a:prstGeom prst="rect">
@@ -4931,7 +5007,7 @@
         </p:nvSpPr>
         <p:spPr>
           <a:xfrm>
-            <a:off x="731520" y="6035040"/>
+            <a:off x="731520" y="5325897"/>
             <a:ext cx="10698480" cy="338328"/>
           </a:xfrm>
           <a:prstGeom prst="rect">
@@ -4963,6 +5039,7 @@
           <a:lstStyle/>
           <a:p>
             <a:pPr algn="ctr"/>
+            <a:endParaRPr/>
           </a:p>
         </p:txBody>
       </p:sp>
@@ -4974,7 +5051,7 @@
         </p:nvSpPr>
         <p:spPr>
           <a:xfrm>
-            <a:off x="914400" y="6044184"/>
+            <a:off x="914400" y="5354992"/>
             <a:ext cx="7772400" cy="301752"/>
           </a:xfrm>
           <a:prstGeom prst="rect">
@@ -5010,7 +5087,7 @@
         </p:nvSpPr>
         <p:spPr>
           <a:xfrm>
-            <a:off x="8961120" y="6044184"/>
+            <a:off x="8961120" y="5335041"/>
             <a:ext cx="2468880" cy="301752"/>
           </a:xfrm>
           <a:prstGeom prst="rect">
@@ -5046,7 +5123,7 @@
         </p:nvSpPr>
         <p:spPr>
           <a:xfrm>
-            <a:off x="731520" y="6483096"/>
+            <a:off x="731520" y="5773953"/>
             <a:ext cx="10698480" cy="548640"/>
           </a:xfrm>
           <a:prstGeom prst="rect">
@@ -5078,6 +5155,7 @@
           <a:lstStyle/>
           <a:p>
             <a:pPr algn="ctr"/>
+            <a:endParaRPr/>
           </a:p>
         </p:txBody>
       </p:sp>
@@ -5089,7 +5167,7 @@
         </p:nvSpPr>
         <p:spPr>
           <a:xfrm>
-            <a:off x="914400" y="6556248"/>
+            <a:off x="914400" y="5847105"/>
             <a:ext cx="7772400" cy="411480"/>
           </a:xfrm>
           <a:prstGeom prst="rect">
@@ -5112,7 +5190,7 @@
               </a:defRPr>
             </a:pPr>
             <a:r>
-              <a:t>TOTALE (IVA esclusa)</a:t>
+              <a:t>TOTALE con sconto 35% (IVA esclusa)</a:t>
             </a:r>
           </a:p>
         </p:txBody>
@@ -5125,7 +5203,7 @@
         </p:nvSpPr>
         <p:spPr>
           <a:xfrm>
-            <a:off x="8961120" y="6556248"/>
+            <a:off x="8961120" y="5847105"/>
             <a:ext cx="2468880" cy="411480"/>
           </a:xfrm>
           <a:prstGeom prst="rect">
@@ -5148,7 +5226,8 @@
               </a:defRPr>
             </a:pPr>
             <a:r>
-              <a:t>670,00 €</a:t>
+              <a:rPr dirty="0"/>
+              <a:t>435,50 €</a:t>
             </a:r>
           </a:p>
         </p:txBody>
@@ -5161,7 +5240,7 @@
         </p:nvSpPr>
         <p:spPr>
           <a:xfrm>
-            <a:off x="731520" y="7214616"/>
+            <a:off x="731520" y="6505473"/>
             <a:ext cx="10698480" cy="365760"/>
           </a:xfrm>
           <a:prstGeom prst="rect">
@@ -5184,7 +5263,7 @@
               </a:defRPr>
             </a:pPr>
             <a:r>
-              <a:t>Risparmio rispetto alla media di mercato: oltre il 50%  (Media web agency per refactoring: 1.500 - 3.000 €)</a:t>
+              <a:t>Prezzo di listino: 670,00 € — Sconto 35% applicato — Risparmio rispetto alla media di mercato: oltre il 65%</a:t>
             </a:r>
           </a:p>
         </p:txBody>
@@ -5198,7 +5277,7 @@
 </file>
 
 <file path=ppt/slides/slide11.xml><?xml version="1.0" encoding="utf-8"?>
-<p:sld xmlns:a="http://schemas.openxmlformats.org/drawingml/2006/main" xmlns:p="http://schemas.openxmlformats.org/presentationml/2006/main" xmlns:r="http://schemas.openxmlformats.org/officeDocument/2006/relationships">
+<p:sld xmlns:a="http://schemas.openxmlformats.org/drawingml/2006/main" xmlns:r="http://schemas.openxmlformats.org/officeDocument/2006/relationships" xmlns:p="http://schemas.openxmlformats.org/presentationml/2006/main">
   <p:cSld>
     <p:bg>
       <p:bgPr>
@@ -5214,7 +5293,14 @@
         <p:cNvGrpSpPr/>
         <p:nvPr/>
       </p:nvGrpSpPr>
-      <p:grpSpPr/>
+      <p:grpSpPr>
+        <a:xfrm>
+          <a:off x="0" y="0"/>
+          <a:ext cx="0" cy="0"/>
+          <a:chOff x="0" y="0"/>
+          <a:chExt cx="0" cy="0"/>
+        </a:xfrm>
+      </p:grpSpPr>
       <p:sp>
         <p:nvSpPr>
           <p:cNvPr id="2" name="TextBox 1"/>
@@ -5291,6 +5377,7 @@
           <a:lstStyle/>
           <a:p>
             <a:pPr algn="ctr"/>
+            <a:endParaRPr/>
           </a:p>
         </p:txBody>
       </p:sp>
@@ -5370,6 +5457,7 @@
           <a:lstStyle/>
           <a:p>
             <a:pPr algn="ctr"/>
+            <a:endParaRPr/>
           </a:p>
         </p:txBody>
       </p:sp>
@@ -5449,6 +5537,7 @@
           <a:lstStyle/>
           <a:p>
             <a:pPr algn="ctr"/>
+            <a:endParaRPr/>
           </a:p>
         </p:txBody>
       </p:sp>
@@ -5528,6 +5617,7 @@
           <a:lstStyle/>
           <a:p>
             <a:pPr algn="ctr"/>
+            <a:endParaRPr/>
           </a:p>
         </p:txBody>
       </p:sp>
@@ -5643,6 +5733,7 @@
           <a:lstStyle/>
           <a:p>
             <a:pPr algn="ctr"/>
+            <a:endParaRPr/>
           </a:p>
         </p:txBody>
       </p:sp>
@@ -5727,7 +5818,7 @@
         <p:spPr>
           <a:xfrm>
             <a:off x="731520" y="3246120"/>
-            <a:ext cx="4572000" cy="384048"/>
+            <a:ext cx="4572000" cy="566928"/>
           </a:xfrm>
           <a:prstGeom prst="rect">
             <a:avLst/>
@@ -5758,6 +5849,7 @@
           <a:lstStyle/>
           <a:p>
             <a:pPr algn="ctr"/>
+            <a:endParaRPr/>
           </a:p>
         </p:txBody>
       </p:sp>
@@ -5770,7 +5862,7 @@
         <p:spPr>
           <a:xfrm>
             <a:off x="822960" y="3273552"/>
-            <a:ext cx="3017520" cy="320040"/>
+            <a:ext cx="3017520" cy="492443"/>
           </a:xfrm>
           <a:prstGeom prst="rect">
             <a:avLst/>
@@ -5792,8 +5884,46 @@
               </a:defRPr>
             </a:pPr>
             <a:r>
-              <a:t>Manutenzione/aggiornamenti</a:t>
-            </a:r>
+              <a:rPr dirty="0" err="1"/>
+              <a:t>Manutenzione</a:t>
+            </a:r>
+            <a:r>
+              <a:rPr dirty="0"/>
+              <a:t> </a:t>
+            </a:r>
+            <a:r>
+              <a:rPr dirty="0" err="1"/>
+              <a:t>annuale</a:t>
+            </a:r>
+            <a:r>
+              <a:rPr dirty="0"/>
+              <a:t>, </a:t>
+            </a:r>
+            <a:r>
+              <a:rPr dirty="0" err="1"/>
+              <a:t>rinnovo</a:t>
+            </a:r>
+            <a:r>
+              <a:rPr dirty="0"/>
+              <a:t> </a:t>
+            </a:r>
+            <a:r>
+              <a:rPr dirty="0" err="1"/>
+              <a:t>certificato</a:t>
+            </a:r>
+            <a:r>
+              <a:rPr dirty="0"/>
+              <a:t> SSL e </a:t>
+            </a:r>
+            <a:r>
+              <a:rPr dirty="0" smtClean="0"/>
+              <a:t>aggiornamenti</a:t>
+            </a:r>
+            <a:r>
+              <a:rPr lang="it-IT" dirty="0" smtClean="0"/>
+              <a:t>/modifiche</a:t>
+            </a:r>
+            <a:endParaRPr dirty="0"/>
           </a:p>
         </p:txBody>
       </p:sp>
@@ -5828,7 +5958,8 @@
               </a:defRPr>
             </a:pPr>
             <a:r>
-              <a:t>Su richiesta</a:t>
+              <a:rPr dirty="0"/>
+              <a:t>100,00 €/anno</a:t>
             </a:r>
           </a:p>
         </p:txBody>
@@ -5878,7 +6009,7 @@
         <p:spPr>
           <a:xfrm>
             <a:off x="6400800" y="1920240"/>
-            <a:ext cx="5029200" cy="2286000"/>
+            <a:ext cx="5029200" cy="1600200"/>
           </a:xfrm>
           <a:prstGeom prst="roundRect">
             <a:avLst/>
@@ -5911,6 +6042,7 @@
           <a:lstStyle/>
           <a:p>
             <a:pPr algn="ctr"/>
+            <a:endParaRPr/>
           </a:p>
         </p:txBody>
       </p:sp>
@@ -5922,7 +6054,7 @@
         </p:nvSpPr>
         <p:spPr>
           <a:xfrm>
-            <a:off x="6675120" y="2194560"/>
+            <a:off x="6665789" y="2115626"/>
             <a:ext cx="4480560" cy="1828800"/>
           </a:xfrm>
           <a:prstGeom prst="rect">
@@ -5945,7 +6077,7 @@
               </a:spcAft>
             </a:pPr>
             <a:r>
-              <a:rPr sz="1100">
+              <a:rPr sz="1100" dirty="0">
                 <a:solidFill>
                   <a:srgbClr val="7B8FA3"/>
                 </a:solidFill>
@@ -5954,13 +6086,67 @@
               <a:t>◆  </a:t>
             </a:r>
             <a:r>
-              <a:rPr sz="1500">
+              <a:rPr sz="1500" dirty="0">
                 <a:solidFill>
                   <a:srgbClr val="8A919C"/>
                 </a:solidFill>
                 <a:latin typeface="Calibri"/>
               </a:rPr>
-              <a:t>50% all'accettazione del preventivo (acconto)</a:t>
+              <a:t>50% </a:t>
+            </a:r>
+            <a:r>
+              <a:rPr sz="1500" dirty="0" err="1">
+                <a:solidFill>
+                  <a:srgbClr val="8A919C"/>
+                </a:solidFill>
+                <a:latin typeface="Calibri"/>
+              </a:rPr>
+              <a:t>all'accettazione</a:t>
+            </a:r>
+            <a:r>
+              <a:rPr sz="1500" dirty="0">
+                <a:solidFill>
+                  <a:srgbClr val="8A919C"/>
+                </a:solidFill>
+                <a:latin typeface="Calibri"/>
+              </a:rPr>
+              <a:t> del </a:t>
+            </a:r>
+            <a:r>
+              <a:rPr sz="1500" dirty="0" err="1">
+                <a:solidFill>
+                  <a:srgbClr val="8A919C"/>
+                </a:solidFill>
+                <a:latin typeface="Calibri"/>
+              </a:rPr>
+              <a:t>preventivo</a:t>
+            </a:r>
+            <a:r>
+              <a:rPr sz="1500" dirty="0">
+                <a:solidFill>
+                  <a:srgbClr val="8A919C"/>
+                </a:solidFill>
+                <a:latin typeface="Calibri"/>
+              </a:rPr>
+              <a:t> (</a:t>
+            </a:r>
+            <a:r>
+              <a:rPr sz="1500" dirty="0" err="1">
+                <a:solidFill>
+                  <a:srgbClr val="8A919C"/>
+                </a:solidFill>
+                <a:latin typeface="Calibri"/>
+              </a:rPr>
+              <a:t>acconto</a:t>
+            </a:r>
+            <a:r>
+              <a:rPr sz="1500" dirty="0">
+                <a:solidFill>
+                  <a:srgbClr val="8A919C"/>
+                </a:solidFill>
+                <a:latin typeface="Calibri"/>
+              </a:rPr>
+              <a:t>)</a:t>
             </a:r>
           </a:p>
           <a:p>
@@ -5973,7 +6159,7 @@
               </a:spcAft>
             </a:pPr>
             <a:r>
-              <a:rPr sz="1100">
+              <a:rPr sz="1100" dirty="0">
                 <a:solidFill>
                   <a:srgbClr val="7B8FA3"/>
                 </a:solidFill>
@@ -5982,14 +6168,83 @@
               <a:t>◆  </a:t>
             </a:r>
             <a:r>
-              <a:rPr sz="1500">
+              <a:rPr sz="1500" dirty="0">
                 <a:solidFill>
                   <a:srgbClr val="8A919C"/>
                 </a:solidFill>
                 <a:latin typeface="Calibri"/>
               </a:rPr>
-              <a:t>50% alla consegna e pubblicazione del sito</a:t>
-            </a:r>
+              <a:t>50% </a:t>
+            </a:r>
+            <a:r>
+              <a:rPr sz="1500" dirty="0" err="1">
+                <a:solidFill>
+                  <a:srgbClr val="8A919C"/>
+                </a:solidFill>
+                <a:latin typeface="Calibri"/>
+              </a:rPr>
+              <a:t>alla</a:t>
+            </a:r>
+            <a:r>
+              <a:rPr sz="1500" dirty="0">
+                <a:solidFill>
+                  <a:srgbClr val="8A919C"/>
+                </a:solidFill>
+                <a:latin typeface="Calibri"/>
+              </a:rPr>
+              <a:t> </a:t>
+            </a:r>
+            <a:r>
+              <a:rPr sz="1500" dirty="0" err="1">
+                <a:solidFill>
+                  <a:srgbClr val="8A919C"/>
+                </a:solidFill>
+                <a:latin typeface="Calibri"/>
+              </a:rPr>
+              <a:t>consegna</a:t>
+            </a:r>
+            <a:r>
+              <a:rPr sz="1500" dirty="0">
+                <a:solidFill>
+                  <a:srgbClr val="8A919C"/>
+                </a:solidFill>
+                <a:latin typeface="Calibri"/>
+              </a:rPr>
+              <a:t> e </a:t>
+            </a:r>
+            <a:r>
+              <a:rPr sz="1500" dirty="0" err="1">
+                <a:solidFill>
+                  <a:srgbClr val="8A919C"/>
+                </a:solidFill>
+                <a:latin typeface="Calibri"/>
+              </a:rPr>
+              <a:t>pubblicazione</a:t>
+            </a:r>
+            <a:r>
+              <a:rPr sz="1500" dirty="0">
+                <a:solidFill>
+                  <a:srgbClr val="8A919C"/>
+                </a:solidFill>
+                <a:latin typeface="Calibri"/>
+              </a:rPr>
+              <a:t> del </a:t>
+            </a:r>
+            <a:r>
+              <a:rPr sz="1500" dirty="0" err="1">
+                <a:solidFill>
+                  <a:srgbClr val="8A919C"/>
+                </a:solidFill>
+                <a:latin typeface="Calibri"/>
+              </a:rPr>
+              <a:t>sito</a:t>
+            </a:r>
+            <a:endParaRPr sz="1500" dirty="0">
+              <a:solidFill>
+                <a:srgbClr val="8A919C"/>
+              </a:solidFill>
+              <a:latin typeface="Calibri"/>
+            </a:endParaRPr>
           </a:p>
           <a:p>
             <a:pPr>
@@ -6001,7 +6256,7 @@
               </a:spcAft>
             </a:pPr>
             <a:r>
-              <a:rPr sz="1100">
+              <a:rPr sz="1100" dirty="0">
                 <a:solidFill>
                   <a:srgbClr val="7B8FA3"/>
                 </a:solidFill>
@@ -6010,14 +6265,92 @@
               <a:t>◆  </a:t>
             </a:r>
             <a:r>
-              <a:rPr sz="1500">
+              <a:rPr sz="1500" dirty="0" err="1">
                 <a:solidFill>
                   <a:srgbClr val="8A919C"/>
                 </a:solidFill>
                 <a:latin typeface="Calibri"/>
               </a:rPr>
-              <a:t>Pagamento tramite bonifico bancario o contanti</a:t>
-            </a:r>
+              <a:t>Pagamento</a:t>
+            </a:r>
+            <a:r>
+              <a:rPr sz="1500" dirty="0">
+                <a:solidFill>
+                  <a:srgbClr val="8A919C"/>
+                </a:solidFill>
+                <a:latin typeface="Calibri"/>
+              </a:rPr>
+              <a:t> </a:t>
+            </a:r>
+            <a:r>
+              <a:rPr sz="1500" dirty="0" err="1">
+                <a:solidFill>
+                  <a:srgbClr val="8A919C"/>
+                </a:solidFill>
+                <a:latin typeface="Calibri"/>
+              </a:rPr>
+              <a:t>tramite</a:t>
+            </a:r>
+            <a:r>
+              <a:rPr sz="1500" dirty="0">
+                <a:solidFill>
+                  <a:srgbClr val="8A919C"/>
+                </a:solidFill>
+                <a:latin typeface="Calibri"/>
+              </a:rPr>
+              <a:t> </a:t>
+            </a:r>
+            <a:r>
+              <a:rPr sz="1500" dirty="0" err="1">
+                <a:solidFill>
+                  <a:srgbClr val="8A919C"/>
+                </a:solidFill>
+                <a:latin typeface="Calibri"/>
+              </a:rPr>
+              <a:t>bonifico</a:t>
+            </a:r>
+            <a:r>
+              <a:rPr sz="1500" dirty="0">
+                <a:solidFill>
+                  <a:srgbClr val="8A919C"/>
+                </a:solidFill>
+                <a:latin typeface="Calibri"/>
+              </a:rPr>
+              <a:t> </a:t>
+            </a:r>
+            <a:r>
+              <a:rPr sz="1500" dirty="0" err="1">
+                <a:solidFill>
+                  <a:srgbClr val="8A919C"/>
+                </a:solidFill>
+                <a:latin typeface="Calibri"/>
+              </a:rPr>
+              <a:t>bancario</a:t>
+            </a:r>
+            <a:r>
+              <a:rPr sz="1500" dirty="0">
+                <a:solidFill>
+                  <a:srgbClr val="8A919C"/>
+                </a:solidFill>
+                <a:latin typeface="Calibri"/>
+              </a:rPr>
+              <a:t> o </a:t>
+            </a:r>
+            <a:r>
+              <a:rPr sz="1500" dirty="0" err="1">
+                <a:solidFill>
+                  <a:srgbClr val="8A919C"/>
+                </a:solidFill>
+                <a:latin typeface="Calibri"/>
+              </a:rPr>
+              <a:t>contanti</a:t>
+            </a:r>
+            <a:endParaRPr sz="1500" dirty="0">
+              <a:solidFill>
+                <a:srgbClr val="8A919C"/>
+              </a:solidFill>
+              <a:latin typeface="Calibri"/>
+            </a:endParaRPr>
           </a:p>
         </p:txBody>
       </p:sp>
@@ -6063,6 +6396,7 @@
           <a:lstStyle/>
           <a:p>
             <a:pPr algn="ctr"/>
+            <a:endParaRPr/>
           </a:p>
         </p:txBody>
       </p:sp>
@@ -6097,7 +6431,8 @@
               </a:defRPr>
             </a:pPr>
             <a:r>
-              <a:t>RIEPILOGO INVESTIMENTO</a:t>
+              <a:rPr dirty="0"/>
+              <a:t>OFFERTA SPECIALE</a:t>
             </a:r>
           </a:p>
         </p:txBody>
@@ -6110,8 +6445,8 @@
         </p:nvSpPr>
         <p:spPr>
           <a:xfrm>
-            <a:off x="1828800" y="4846320"/>
-            <a:ext cx="8534095" cy="731520"/>
+            <a:off x="1828800" y="4640487"/>
+            <a:ext cx="8534095" cy="1200329"/>
           </a:xfrm>
           <a:prstGeom prst="rect">
             <a:avLst/>
@@ -6133,7 +6468,30 @@
               </a:defRPr>
             </a:pPr>
             <a:r>
-              <a:t>670,00 €</a:t>
+              <a:rPr sz="2800" strike="sngStrike" dirty="0">
+                <a:solidFill>
+                  <a:srgbClr val="8A919C"/>
+                </a:solidFill>
+              </a:rPr>
+              <a:t>435,50 €</a:t>
+            </a:r>
+          </a:p>
+          <a:p>
+            <a:pPr algn="ctr">
+              <a:defRPr sz="4800" b="1">
+                <a:solidFill>
+                  <a:srgbClr val="E8EAED"/>
+                </a:solidFill>
+                <a:latin typeface="Georgia"/>
+              </a:defRPr>
+            </a:pPr>
+            <a:r>
+              <a:rPr sz="4400" b="1" dirty="0">
+                <a:solidFill>
+                  <a:srgbClr val="7B8FA3"/>
+                </a:solidFill>
+              </a:rPr>
+              <a:t>305,00 €</a:t>
             </a:r>
           </a:p>
         </p:txBody>
@@ -6146,7 +6504,7 @@
         </p:nvSpPr>
         <p:spPr>
           <a:xfrm>
-            <a:off x="1828800" y="5486400"/>
+            <a:off x="1828800" y="5760720"/>
             <a:ext cx="8534095" cy="365760"/>
           </a:xfrm>
           <a:prstGeom prst="rect">
@@ -6169,8 +6527,62 @@
               </a:defRPr>
             </a:pPr>
             <a:r>
-              <a:t>IVA esclusa  •  Hosting gratuito incluso  •  Codice di proprietà del cliente</a:t>
-            </a:r>
+              <a:rPr dirty="0"/>
+              <a:t>IVA </a:t>
+            </a:r>
+            <a:r>
+              <a:rPr dirty="0" err="1"/>
+              <a:t>esclusa</a:t>
+            </a:r>
+            <a:r>
+              <a:rPr dirty="0"/>
+              <a:t>  •  Hosting </a:t>
+            </a:r>
+            <a:r>
+              <a:rPr dirty="0" err="1"/>
+              <a:t>gratuito</a:t>
+            </a:r>
+            <a:r>
+              <a:rPr dirty="0"/>
+              <a:t>  •  </a:t>
+            </a:r>
+            <a:r>
+              <a:rPr dirty="0" err="1"/>
+              <a:t>Canone</a:t>
+            </a:r>
+            <a:r>
+              <a:rPr dirty="0"/>
+              <a:t> </a:t>
+            </a:r>
+            <a:r>
+              <a:rPr dirty="0" err="1"/>
+              <a:t>annuale</a:t>
+            </a:r>
+            <a:r>
+              <a:rPr dirty="0"/>
+              <a:t> 100 €  •  </a:t>
+            </a:r>
+            <a:r>
+              <a:rPr dirty="0" err="1"/>
+              <a:t>Sconto</a:t>
+            </a:r>
+            <a:r>
+              <a:rPr dirty="0"/>
+              <a:t> 35% + </a:t>
+            </a:r>
+            <a:r>
+              <a:rPr dirty="0" err="1"/>
+              <a:t>ulteriore</a:t>
+            </a:r>
+            <a:r>
+              <a:rPr dirty="0"/>
+              <a:t> 30% </a:t>
+            </a:r>
+            <a:r>
+              <a:rPr dirty="0" err="1"/>
+              <a:t>applicati</a:t>
+            </a:r>
+            <a:endParaRPr dirty="0"/>
           </a:p>
         </p:txBody>
       </p:sp>
@@ -6183,7 +6595,7 @@
 </file>
 
 <file path=ppt/slides/slide12.xml><?xml version="1.0" encoding="utf-8"?>
-<p:sld xmlns:a="http://schemas.openxmlformats.org/drawingml/2006/main" xmlns:p="http://schemas.openxmlformats.org/presentationml/2006/main" xmlns:r="http://schemas.openxmlformats.org/officeDocument/2006/relationships">
+<p:sld xmlns:a="http://schemas.openxmlformats.org/drawingml/2006/main" xmlns:r="http://schemas.openxmlformats.org/officeDocument/2006/relationships" xmlns:p="http://schemas.openxmlformats.org/presentationml/2006/main">
   <p:cSld>
     <p:bg>
       <p:bgPr>
@@ -6199,7 +6611,14 @@
         <p:cNvGrpSpPr/>
         <p:nvPr/>
       </p:nvGrpSpPr>
-      <p:grpSpPr/>
+      <p:grpSpPr>
+        <a:xfrm>
+          <a:off x="0" y="0"/>
+          <a:ext cx="0" cy="0"/>
+          <a:chOff x="0" y="0"/>
+          <a:chExt cx="0" cy="0"/>
+        </a:xfrm>
+      </p:grpSpPr>
       <p:sp>
         <p:nvSpPr>
           <p:cNvPr id="2" name="Rectangle 1"/>
@@ -6240,6 +6659,7 @@
           <a:lstStyle/>
           <a:p>
             <a:pPr algn="ctr"/>
+            <a:endParaRPr/>
           </a:p>
         </p:txBody>
       </p:sp>
@@ -6359,6 +6779,7 @@
           <a:lstStyle/>
           <a:p>
             <a:pPr algn="ctr"/>
+            <a:endParaRPr/>
           </a:p>
         </p:txBody>
       </p:sp>
@@ -6510,6 +6931,7 @@
           <a:lstStyle/>
           <a:p>
             <a:pPr algn="ctr"/>
+            <a:endParaRPr/>
           </a:p>
         </p:txBody>
       </p:sp>
@@ -6522,7 +6944,7 @@
 </file>
 
 <file path=ppt/slides/slide2.xml><?xml version="1.0" encoding="utf-8"?>
-<p:sld xmlns:a="http://schemas.openxmlformats.org/drawingml/2006/main" xmlns:p="http://schemas.openxmlformats.org/presentationml/2006/main" xmlns:r="http://schemas.openxmlformats.org/officeDocument/2006/relationships">
+<p:sld xmlns:a="http://schemas.openxmlformats.org/drawingml/2006/main" xmlns:r="http://schemas.openxmlformats.org/officeDocument/2006/relationships" xmlns:p="http://schemas.openxmlformats.org/presentationml/2006/main">
   <p:cSld>
     <p:bg>
       <p:bgPr>
@@ -6538,7 +6960,14 @@
         <p:cNvGrpSpPr/>
         <p:nvPr/>
       </p:nvGrpSpPr>
-      <p:grpSpPr/>
+      <p:grpSpPr>
+        <a:xfrm>
+          <a:off x="0" y="0"/>
+          <a:ext cx="0" cy="0"/>
+          <a:chOff x="0" y="0"/>
+          <a:chExt cx="0" cy="0"/>
+        </a:xfrm>
+      </p:grpSpPr>
       <p:sp>
         <p:nvSpPr>
           <p:cNvPr id="2" name="TextBox 1"/>
@@ -6547,7 +6976,7 @@
         </p:nvSpPr>
         <p:spPr>
           <a:xfrm>
-            <a:off x="731520" y="365760"/>
+            <a:off x="731520" y="337768"/>
             <a:ext cx="5486400" cy="548640"/>
           </a:xfrm>
           <a:prstGeom prst="rect">
@@ -6615,6 +7044,7 @@
           <a:lstStyle/>
           <a:p>
             <a:pPr algn="ctr"/>
+            <a:endParaRPr/>
           </a:p>
         </p:txBody>
       </p:sp>
@@ -6626,8 +7056,8 @@
         </p:nvSpPr>
         <p:spPr>
           <a:xfrm>
-            <a:off x="731520" y="1097280"/>
-            <a:ext cx="10515600" cy="731520"/>
+            <a:off x="731520" y="922642"/>
+            <a:ext cx="10972799" cy="553998"/>
           </a:xfrm>
           <a:prstGeom prst="rect">
             <a:avLst/>
@@ -6649,8 +7079,22 @@
               </a:defRPr>
             </a:pPr>
             <a:r>
-              <a:t>agenziafunebrefratellidirosa.com — I problemi rilevati</a:t>
-            </a:r>
+              <a:rPr dirty="0"/>
+              <a:t>agenziafunebrefratellidirosa.com — I </a:t>
+            </a:r>
+            <a:r>
+              <a:rPr dirty="0" err="1"/>
+              <a:t>problemi</a:t>
+            </a:r>
+            <a:r>
+              <a:rPr dirty="0"/>
+              <a:t> </a:t>
+            </a:r>
+            <a:r>
+              <a:rPr lang="it-IT" dirty="0" smtClean="0"/>
+              <a:t>attuali</a:t>
+            </a:r>
+            <a:endParaRPr dirty="0"/>
           </a:p>
         </p:txBody>
       </p:sp>
@@ -6732,6 +7176,7 @@
           <a:lstStyle/>
           <a:p>
             <a:pPr algn="ctr"/>
+            <a:endParaRPr/>
           </a:p>
         </p:txBody>
       </p:sp>
@@ -6893,6 +7338,7 @@
           <a:lstStyle/>
           <a:p>
             <a:pPr algn="ctr"/>
+            <a:endParaRPr/>
           </a:p>
         </p:txBody>
       </p:sp>
@@ -7054,6 +7500,7 @@
           <a:lstStyle/>
           <a:p>
             <a:pPr algn="ctr"/>
+            <a:endParaRPr/>
           </a:p>
         </p:txBody>
       </p:sp>
@@ -7215,6 +7662,7 @@
           <a:lstStyle/>
           <a:p>
             <a:pPr algn="ctr"/>
+            <a:endParaRPr/>
           </a:p>
         </p:txBody>
       </p:sp>
@@ -7376,6 +7824,7 @@
           <a:lstStyle/>
           <a:p>
             <a:pPr algn="ctr"/>
+            <a:endParaRPr/>
           </a:p>
         </p:txBody>
       </p:sp>
@@ -7537,6 +7986,7 @@
           <a:lstStyle/>
           <a:p>
             <a:pPr algn="ctr"/>
+            <a:endParaRPr/>
           </a:p>
         </p:txBody>
       </p:sp>
@@ -7665,7 +8115,7 @@
 </file>
 
 <file path=ppt/slides/slide3.xml><?xml version="1.0" encoding="utf-8"?>
-<p:sld xmlns:a="http://schemas.openxmlformats.org/drawingml/2006/main" xmlns:p="http://schemas.openxmlformats.org/presentationml/2006/main" xmlns:r="http://schemas.openxmlformats.org/officeDocument/2006/relationships">
+<p:sld xmlns:a="http://schemas.openxmlformats.org/drawingml/2006/main" xmlns:r="http://schemas.openxmlformats.org/officeDocument/2006/relationships" xmlns:p="http://schemas.openxmlformats.org/presentationml/2006/main">
   <p:cSld>
     <p:bg>
       <p:bgPr>
@@ -7681,7 +8131,14 @@
         <p:cNvGrpSpPr/>
         <p:nvPr/>
       </p:nvGrpSpPr>
-      <p:grpSpPr/>
+      <p:grpSpPr>
+        <a:xfrm>
+          <a:off x="0" y="0"/>
+          <a:ext cx="0" cy="0"/>
+          <a:chOff x="0" y="0"/>
+          <a:chExt cx="0" cy="0"/>
+        </a:xfrm>
+      </p:grpSpPr>
       <p:sp>
         <p:nvSpPr>
           <p:cNvPr id="2" name="TextBox 1"/>
@@ -7758,6 +8215,7 @@
           <a:lstStyle/>
           <a:p>
             <a:pPr algn="ctr"/>
+            <a:endParaRPr/>
           </a:p>
         </p:txBody>
       </p:sp>
@@ -7839,6 +8297,7 @@
           <a:lstStyle/>
           <a:p>
             <a:pPr algn="ctr"/>
+            <a:endParaRPr/>
           </a:p>
         </p:txBody>
       </p:sp>
@@ -8000,6 +8459,7 @@
           <a:lstStyle/>
           <a:p>
             <a:pPr algn="ctr"/>
+            <a:endParaRPr/>
           </a:p>
         </p:txBody>
       </p:sp>
@@ -8161,6 +8621,7 @@
           <a:lstStyle/>
           <a:p>
             <a:pPr algn="ctr"/>
+            <a:endParaRPr/>
           </a:p>
         </p:txBody>
       </p:sp>
@@ -8322,6 +8783,7 @@
           <a:lstStyle/>
           <a:p>
             <a:pPr algn="ctr"/>
+            <a:endParaRPr/>
           </a:p>
         </p:txBody>
       </p:sp>
@@ -8370,7 +8832,7 @@
 </file>
 
 <file path=ppt/slides/slide4.xml><?xml version="1.0" encoding="utf-8"?>
-<p:sld xmlns:a="http://schemas.openxmlformats.org/drawingml/2006/main" xmlns:p="http://schemas.openxmlformats.org/presentationml/2006/main" xmlns:r="http://schemas.openxmlformats.org/officeDocument/2006/relationships">
+<p:sld xmlns:a="http://schemas.openxmlformats.org/drawingml/2006/main" xmlns:r="http://schemas.openxmlformats.org/officeDocument/2006/relationships" xmlns:p="http://schemas.openxmlformats.org/presentationml/2006/main">
   <p:cSld>
     <p:bg>
       <p:bgPr>
@@ -8386,7 +8848,14 @@
         <p:cNvGrpSpPr/>
         <p:nvPr/>
       </p:nvGrpSpPr>
-      <p:grpSpPr/>
+      <p:grpSpPr>
+        <a:xfrm>
+          <a:off x="0" y="0"/>
+          <a:ext cx="0" cy="0"/>
+          <a:chOff x="0" y="0"/>
+          <a:chExt cx="0" cy="0"/>
+        </a:xfrm>
+      </p:grpSpPr>
       <p:sp>
         <p:nvSpPr>
           <p:cNvPr id="2" name="TextBox 1"/>
@@ -8463,6 +8932,7 @@
           <a:lstStyle/>
           <a:p>
             <a:pPr algn="ctr"/>
+            <a:endParaRPr/>
           </a:p>
         </p:txBody>
       </p:sp>
@@ -8580,6 +9050,7 @@
           <a:lstStyle/>
           <a:p>
             <a:pPr algn="ctr"/>
+            <a:endParaRPr/>
           </a:p>
         </p:txBody>
       </p:sp>
@@ -8741,6 +9212,7 @@
           <a:lstStyle/>
           <a:p>
             <a:pPr algn="ctr"/>
+            <a:endParaRPr/>
           </a:p>
         </p:txBody>
       </p:sp>
@@ -8902,6 +9374,7 @@
           <a:lstStyle/>
           <a:p>
             <a:pPr algn="ctr"/>
+            <a:endParaRPr/>
           </a:p>
         </p:txBody>
       </p:sp>
@@ -9063,6 +9536,7 @@
           <a:lstStyle/>
           <a:p>
             <a:pPr algn="ctr"/>
+            <a:endParaRPr/>
           </a:p>
         </p:txBody>
       </p:sp>
@@ -9224,6 +9698,7 @@
           <a:lstStyle/>
           <a:p>
             <a:pPr algn="ctr"/>
+            <a:endParaRPr/>
           </a:p>
         </p:txBody>
       </p:sp>
@@ -9385,6 +9860,7 @@
           <a:lstStyle/>
           <a:p>
             <a:pPr algn="ctr"/>
+            <a:endParaRPr/>
           </a:p>
         </p:txBody>
       </p:sp>
@@ -9513,7 +9989,7 @@
 </file>
 
 <file path=ppt/slides/slide5.xml><?xml version="1.0" encoding="utf-8"?>
-<p:sld xmlns:a="http://schemas.openxmlformats.org/drawingml/2006/main" xmlns:p="http://schemas.openxmlformats.org/presentationml/2006/main" xmlns:r="http://schemas.openxmlformats.org/officeDocument/2006/relationships">
+<p:sld xmlns:a="http://schemas.openxmlformats.org/drawingml/2006/main" xmlns:r="http://schemas.openxmlformats.org/officeDocument/2006/relationships" xmlns:p="http://schemas.openxmlformats.org/presentationml/2006/main">
   <p:cSld>
     <p:bg>
       <p:bgPr>
@@ -9529,7 +10005,14 @@
         <p:cNvGrpSpPr/>
         <p:nvPr/>
       </p:nvGrpSpPr>
-      <p:grpSpPr/>
+      <p:grpSpPr>
+        <a:xfrm>
+          <a:off x="0" y="0"/>
+          <a:ext cx="0" cy="0"/>
+          <a:chOff x="0" y="0"/>
+          <a:chExt cx="0" cy="0"/>
+        </a:xfrm>
+      </p:grpSpPr>
       <p:sp>
         <p:nvSpPr>
           <p:cNvPr id="2" name="TextBox 1"/>
@@ -9606,6 +10089,7 @@
           <a:lstStyle/>
           <a:p>
             <a:pPr algn="ctr"/>
+            <a:endParaRPr/>
           </a:p>
         </p:txBody>
       </p:sp>
@@ -9685,6 +10169,7 @@
           <a:lstStyle/>
           <a:p>
             <a:pPr algn="ctr"/>
+            <a:endParaRPr/>
           </a:p>
         </p:txBody>
       </p:sp>
@@ -9764,6 +10249,7 @@
           <a:lstStyle/>
           <a:p>
             <a:pPr algn="ctr"/>
+            <a:endParaRPr/>
           </a:p>
         </p:txBody>
       </p:sp>
@@ -9843,6 +10329,7 @@
           <a:lstStyle/>
           <a:p>
             <a:pPr algn="ctr"/>
+            <a:endParaRPr/>
           </a:p>
         </p:txBody>
       </p:sp>
@@ -9922,6 +10409,7 @@
           <a:lstStyle/>
           <a:p>
             <a:pPr algn="ctr"/>
+            <a:endParaRPr/>
           </a:p>
         </p:txBody>
       </p:sp>
@@ -10073,6 +10561,7 @@
           <a:lstStyle/>
           <a:p>
             <a:pPr algn="ctr"/>
+            <a:endParaRPr/>
           </a:p>
         </p:txBody>
       </p:sp>
@@ -10224,6 +10713,7 @@
           <a:lstStyle/>
           <a:p>
             <a:pPr algn="ctr"/>
+            <a:endParaRPr/>
           </a:p>
         </p:txBody>
       </p:sp>
@@ -10375,6 +10865,7 @@
           <a:lstStyle/>
           <a:p>
             <a:pPr algn="ctr"/>
+            <a:endParaRPr/>
           </a:p>
         </p:txBody>
       </p:sp>
@@ -10526,6 +11017,7 @@
           <a:lstStyle/>
           <a:p>
             <a:pPr algn="ctr"/>
+            <a:endParaRPr/>
           </a:p>
         </p:txBody>
       </p:sp>
@@ -10677,6 +11169,7 @@
           <a:lstStyle/>
           <a:p>
             <a:pPr algn="ctr"/>
+            <a:endParaRPr/>
           </a:p>
         </p:txBody>
       </p:sp>
@@ -10828,6 +11321,7 @@
           <a:lstStyle/>
           <a:p>
             <a:pPr algn="ctr"/>
+            <a:endParaRPr/>
           </a:p>
         </p:txBody>
       </p:sp>
@@ -10979,6 +11473,7 @@
           <a:lstStyle/>
           <a:p>
             <a:pPr algn="ctr"/>
+            <a:endParaRPr/>
           </a:p>
         </p:txBody>
       </p:sp>
@@ -11130,6 +11625,7 @@
           <a:lstStyle/>
           <a:p>
             <a:pPr algn="ctr"/>
+            <a:endParaRPr/>
           </a:p>
         </p:txBody>
       </p:sp>
@@ -11281,6 +11777,7 @@
           <a:lstStyle/>
           <a:p>
             <a:pPr algn="ctr"/>
+            <a:endParaRPr/>
           </a:p>
         </p:txBody>
       </p:sp>
@@ -11401,7 +11898,7 @@
 </file>
 
 <file path=ppt/slides/slide6.xml><?xml version="1.0" encoding="utf-8"?>
-<p:sld xmlns:a="http://schemas.openxmlformats.org/drawingml/2006/main" xmlns:p="http://schemas.openxmlformats.org/presentationml/2006/main" xmlns:r="http://schemas.openxmlformats.org/officeDocument/2006/relationships">
+<p:sld xmlns:a="http://schemas.openxmlformats.org/drawingml/2006/main" xmlns:r="http://schemas.openxmlformats.org/officeDocument/2006/relationships" xmlns:p="http://schemas.openxmlformats.org/presentationml/2006/main">
   <p:cSld>
     <p:bg>
       <p:bgPr>
@@ -11417,7 +11914,14 @@
         <p:cNvGrpSpPr/>
         <p:nvPr/>
       </p:nvGrpSpPr>
-      <p:grpSpPr/>
+      <p:grpSpPr>
+        <a:xfrm>
+          <a:off x="0" y="0"/>
+          <a:ext cx="0" cy="0"/>
+          <a:chOff x="0" y="0"/>
+          <a:chExt cx="0" cy="0"/>
+        </a:xfrm>
+      </p:grpSpPr>
       <p:sp>
         <p:nvSpPr>
           <p:cNvPr id="2" name="TextBox 1"/>
@@ -11494,6 +11998,7 @@
           <a:lstStyle/>
           <a:p>
             <a:pPr algn="ctr"/>
+            <a:endParaRPr/>
           </a:p>
         </p:txBody>
       </p:sp>
@@ -11575,6 +12080,7 @@
           <a:lstStyle/>
           <a:p>
             <a:pPr algn="ctr"/>
+            <a:endParaRPr/>
           </a:p>
         </p:txBody>
       </p:sp>
@@ -11736,6 +12242,7 @@
           <a:lstStyle/>
           <a:p>
             <a:pPr algn="ctr"/>
+            <a:endParaRPr/>
           </a:p>
         </p:txBody>
       </p:sp>
@@ -11897,6 +12404,7 @@
           <a:lstStyle/>
           <a:p>
             <a:pPr algn="ctr"/>
+            <a:endParaRPr/>
           </a:p>
         </p:txBody>
       </p:sp>
@@ -12058,6 +12566,7 @@
           <a:lstStyle/>
           <a:p>
             <a:pPr algn="ctr"/>
+            <a:endParaRPr/>
           </a:p>
         </p:txBody>
       </p:sp>
@@ -12219,6 +12728,7 @@
           <a:lstStyle/>
           <a:p>
             <a:pPr algn="ctr"/>
+            <a:endParaRPr/>
           </a:p>
         </p:txBody>
       </p:sp>
@@ -12380,6 +12890,7 @@
           <a:lstStyle/>
           <a:p>
             <a:pPr algn="ctr"/>
+            <a:endParaRPr/>
           </a:p>
         </p:txBody>
       </p:sp>
@@ -12541,6 +13052,7 @@
           <a:lstStyle/>
           <a:p>
             <a:pPr algn="ctr"/>
+            <a:endParaRPr/>
           </a:p>
         </p:txBody>
       </p:sp>
@@ -12669,7 +13181,7 @@
 </file>
 
 <file path=ppt/slides/slide7.xml><?xml version="1.0" encoding="utf-8"?>
-<p:sld xmlns:a="http://schemas.openxmlformats.org/drawingml/2006/main" xmlns:p="http://schemas.openxmlformats.org/presentationml/2006/main" xmlns:r="http://schemas.openxmlformats.org/officeDocument/2006/relationships">
+<p:sld xmlns:a="http://schemas.openxmlformats.org/drawingml/2006/main" xmlns:r="http://schemas.openxmlformats.org/officeDocument/2006/relationships" xmlns:p="http://schemas.openxmlformats.org/presentationml/2006/main">
   <p:cSld>
     <p:bg>
       <p:bgPr>
@@ -12685,7 +13197,14 @@
         <p:cNvGrpSpPr/>
         <p:nvPr/>
       </p:nvGrpSpPr>
-      <p:grpSpPr/>
+      <p:grpSpPr>
+        <a:xfrm>
+          <a:off x="0" y="0"/>
+          <a:ext cx="0" cy="0"/>
+          <a:chOff x="0" y="0"/>
+          <a:chExt cx="0" cy="0"/>
+        </a:xfrm>
+      </p:grpSpPr>
       <p:sp>
         <p:nvSpPr>
           <p:cNvPr id="2" name="TextBox 1"/>
@@ -12694,7 +13213,7 @@
         </p:nvSpPr>
         <p:spPr>
           <a:xfrm>
-            <a:off x="731520" y="365760"/>
+            <a:off x="320973" y="132721"/>
             <a:ext cx="5486400" cy="548640"/>
           </a:xfrm>
           <a:prstGeom prst="rect">
@@ -12717,6 +13236,7 @@
               </a:defRPr>
             </a:pPr>
             <a:r>
+              <a:rPr dirty="0"/>
               <a:t>MOCKUP: HERO SECTION</a:t>
             </a:r>
           </a:p>
@@ -12730,7 +13250,7 @@
         </p:nvSpPr>
         <p:spPr>
           <a:xfrm>
-            <a:off x="731520" y="822960"/>
+            <a:off x="457200" y="586344"/>
             <a:ext cx="1828800" cy="38100"/>
           </a:xfrm>
           <a:prstGeom prst="rect">
@@ -12762,6 +13282,7 @@
           <a:lstStyle/>
           <a:p>
             <a:pPr algn="ctr"/>
+            <a:endParaRPr/>
           </a:p>
         </p:txBody>
       </p:sp>
@@ -12807,49 +13328,7 @@
           <a:lstStyle/>
           <a:p>
             <a:pPr algn="ctr"/>
-          </a:p>
-        </p:txBody>
-      </p:sp>
-      <p:sp>
-        <p:nvSpPr>
-          <p:cNvPr id="5" name="Rectangle 4"/>
-          <p:cNvSpPr/>
-          <p:nvPr/>
-        </p:nvSpPr>
-        <p:spPr>
-          <a:xfrm>
-            <a:off x="1371600" y="1280160"/>
-            <a:ext cx="9448495" cy="548640"/>
-          </a:xfrm>
-          <a:prstGeom prst="rect">
-            <a:avLst/>
-          </a:prstGeom>
-          <a:solidFill>
-            <a:srgbClr val="12151E"/>
-          </a:solidFill>
-          <a:ln>
-            <a:noFill/>
-          </a:ln>
-        </p:spPr>
-        <p:style>
-          <a:lnRef idx="1">
-            <a:schemeClr val="accent1"/>
-          </a:lnRef>
-          <a:fillRef idx="3">
-            <a:schemeClr val="accent1"/>
-          </a:fillRef>
-          <a:effectRef idx="2">
-            <a:schemeClr val="accent1"/>
-          </a:effectRef>
-          <a:fontRef idx="minor">
-            <a:schemeClr val="lt1"/>
-          </a:fontRef>
-        </p:style>
-        <p:txBody>
-          <a:bodyPr rtlCol="0" anchor="ctr"/>
-          <a:lstStyle/>
-          <a:p>
-            <a:pPr algn="ctr"/>
+            <a:endParaRPr/>
           </a:p>
         </p:txBody>
       </p:sp>
@@ -12861,7 +13340,7 @@
         </p:nvSpPr>
         <p:spPr>
           <a:xfrm>
-            <a:off x="1828800" y="1325880"/>
+            <a:off x="1828800" y="1554480"/>
             <a:ext cx="2286000" cy="457200"/>
           </a:xfrm>
           <a:prstGeom prst="rect">
@@ -12884,7 +13363,16 @@
               </a:defRPr>
             </a:pPr>
             <a:r>
-              <a:t>DR  Fratelli Di Rosa</a:t>
+              <a:rPr dirty="0"/>
+              <a:t>DR  </a:t>
+            </a:r>
+            <a:r>
+              <a:rPr dirty="0" err="1"/>
+              <a:t>Fratelli</a:t>
+            </a:r>
+            <a:r>
+              <a:rPr dirty="0"/>
+              <a:t> Di Rosa</a:t>
             </a:r>
           </a:p>
         </p:txBody>
@@ -12897,7 +13385,7 @@
         </p:nvSpPr>
         <p:spPr>
           <a:xfrm>
-            <a:off x="5486400" y="1325880"/>
+            <a:off x="5486400" y="1554480"/>
             <a:ext cx="4572000" cy="457200"/>
           </a:xfrm>
           <a:prstGeom prst="rect">
@@ -12920,8 +13408,30 @@
               </a:defRPr>
             </a:pPr>
             <a:r>
-              <a:t>Home    Chi Siamo    Servizi    Galleria    Contatti</a:t>
-            </a:r>
+              <a:rPr dirty="0"/>
+              <a:t>Home    Chi </a:t>
+            </a:r>
+            <a:r>
+              <a:rPr dirty="0" err="1"/>
+              <a:t>Siamo</a:t>
+            </a:r>
+            <a:r>
+              <a:rPr dirty="0"/>
+              <a:t>    </a:t>
+            </a:r>
+            <a:r>
+              <a:rPr dirty="0" err="1"/>
+              <a:t>Servizi</a:t>
+            </a:r>
+            <a:r>
+              <a:rPr dirty="0"/>
+              <a:t>    Galleria    </a:t>
+            </a:r>
+            <a:r>
+              <a:rPr dirty="0" err="1"/>
+              <a:t>Contatti</a:t>
+            </a:r>
+            <a:endParaRPr dirty="0"/>
           </a:p>
         </p:txBody>
       </p:sp>
@@ -13073,6 +13583,7 @@
           <a:lstStyle/>
           <a:p>
             <a:pPr algn="ctr"/>
+            <a:endParaRPr/>
           </a:p>
         </p:txBody>
       </p:sp>
@@ -13156,6 +13667,7 @@
           <a:lstStyle/>
           <a:p>
             <a:pPr algn="ctr"/>
+            <a:endParaRPr/>
           </a:p>
         </p:txBody>
       </p:sp>
@@ -13235,6 +13747,7 @@
           <a:lstStyle/>
           <a:p>
             <a:pPr algn="ctr"/>
+            <a:endParaRPr/>
           </a:p>
         </p:txBody>
       </p:sp>
@@ -13310,6 +13823,30 @@
           </a:p>
         </p:txBody>
       </p:sp>
+      <p:pic>
+        <p:nvPicPr>
+          <p:cNvPr id="5" name="Immagine 4"/>
+          <p:cNvPicPr>
+            <a:picLocks noChangeAspect="1"/>
+          </p:cNvPicPr>
+          <p:nvPr/>
+        </p:nvPicPr>
+        <p:blipFill>
+          <a:blip r:embed="rId2"/>
+          <a:stretch>
+            <a:fillRect/>
+          </a:stretch>
+        </p:blipFill>
+        <p:spPr>
+          <a:xfrm>
+            <a:off x="1208759" y="761604"/>
+            <a:ext cx="9782701" cy="5959485"/>
+          </a:xfrm>
+          <a:prstGeom prst="rect">
+            <a:avLst/>
+          </a:prstGeom>
+        </p:spPr>
+      </p:pic>
     </p:spTree>
   </p:cSld>
   <p:clrMapOvr>
@@ -13319,7 +13856,7 @@
 </file>
 
 <file path=ppt/slides/slide8.xml><?xml version="1.0" encoding="utf-8"?>
-<p:sld xmlns:a="http://schemas.openxmlformats.org/drawingml/2006/main" xmlns:p="http://schemas.openxmlformats.org/presentationml/2006/main" xmlns:r="http://schemas.openxmlformats.org/officeDocument/2006/relationships">
+<p:sld xmlns:a="http://schemas.openxmlformats.org/drawingml/2006/main" xmlns:r="http://schemas.openxmlformats.org/officeDocument/2006/relationships" xmlns:p="http://schemas.openxmlformats.org/presentationml/2006/main">
   <p:cSld>
     <p:bg>
       <p:bgPr>
@@ -13335,7 +13872,14 @@
         <p:cNvGrpSpPr/>
         <p:nvPr/>
       </p:nvGrpSpPr>
-      <p:grpSpPr/>
+      <p:grpSpPr>
+        <a:xfrm>
+          <a:off x="0" y="0"/>
+          <a:ext cx="0" cy="0"/>
+          <a:chOff x="0" y="0"/>
+          <a:chExt cx="0" cy="0"/>
+        </a:xfrm>
+      </p:grpSpPr>
       <p:sp>
         <p:nvSpPr>
           <p:cNvPr id="2" name="TextBox 1"/>
@@ -13412,6 +13956,7 @@
           <a:lstStyle/>
           <a:p>
             <a:pPr algn="ctr"/>
+            <a:endParaRPr/>
           </a:p>
         </p:txBody>
       </p:sp>
@@ -13493,6 +14038,7 @@
           <a:lstStyle/>
           <a:p>
             <a:pPr algn="ctr"/>
+            <a:endParaRPr/>
           </a:p>
         </p:txBody>
       </p:sp>
@@ -13536,6 +14082,7 @@
           <a:lstStyle/>
           <a:p>
             <a:pPr algn="ctr"/>
+            <a:endParaRPr/>
           </a:p>
         </p:txBody>
       </p:sp>
@@ -13579,6 +14126,7 @@
           <a:lstStyle/>
           <a:p>
             <a:pPr algn="ctr"/>
+            <a:endParaRPr/>
           </a:p>
         </p:txBody>
       </p:sp>
@@ -13700,6 +14248,7 @@
           <a:lstStyle/>
           <a:p>
             <a:pPr algn="ctr"/>
+            <a:endParaRPr/>
           </a:p>
         </p:txBody>
       </p:sp>
@@ -13743,6 +14292,7 @@
           <a:lstStyle/>
           <a:p>
             <a:pPr algn="ctr"/>
+            <a:endParaRPr/>
           </a:p>
         </p:txBody>
       </p:sp>
@@ -13786,6 +14336,7 @@
           <a:lstStyle/>
           <a:p>
             <a:pPr algn="ctr"/>
+            <a:endParaRPr/>
           </a:p>
         </p:txBody>
       </p:sp>
@@ -13907,6 +14458,7 @@
           <a:lstStyle/>
           <a:p>
             <a:pPr algn="ctr"/>
+            <a:endParaRPr/>
           </a:p>
         </p:txBody>
       </p:sp>
@@ -13950,6 +14502,7 @@
           <a:lstStyle/>
           <a:p>
             <a:pPr algn="ctr"/>
+            <a:endParaRPr/>
           </a:p>
         </p:txBody>
       </p:sp>
@@ -13993,6 +14546,7 @@
           <a:lstStyle/>
           <a:p>
             <a:pPr algn="ctr"/>
+            <a:endParaRPr/>
           </a:p>
         </p:txBody>
       </p:sp>
@@ -14110,6 +14664,7 @@
           <a:lstStyle/>
           <a:p>
             <a:pPr algn="ctr"/>
+            <a:endParaRPr/>
           </a:p>
         </p:txBody>
       </p:sp>
@@ -14153,6 +14708,7 @@
           <a:lstStyle/>
           <a:p>
             <a:pPr algn="ctr"/>
+            <a:endParaRPr/>
           </a:p>
         </p:txBody>
       </p:sp>
@@ -14196,6 +14752,7 @@
           <a:lstStyle/>
           <a:p>
             <a:pPr algn="ctr"/>
+            <a:endParaRPr/>
           </a:p>
         </p:txBody>
       </p:sp>
@@ -14317,6 +14874,7 @@
           <a:lstStyle/>
           <a:p>
             <a:pPr algn="ctr"/>
+            <a:endParaRPr/>
           </a:p>
         </p:txBody>
       </p:sp>
@@ -14360,6 +14918,7 @@
           <a:lstStyle/>
           <a:p>
             <a:pPr algn="ctr"/>
+            <a:endParaRPr/>
           </a:p>
         </p:txBody>
       </p:sp>
@@ -14403,6 +14962,7 @@
           <a:lstStyle/>
           <a:p>
             <a:pPr algn="ctr"/>
+            <a:endParaRPr/>
           </a:p>
         </p:txBody>
       </p:sp>
@@ -14524,6 +15084,7 @@
           <a:lstStyle/>
           <a:p>
             <a:pPr algn="ctr"/>
+            <a:endParaRPr/>
           </a:p>
         </p:txBody>
       </p:sp>
@@ -14567,6 +15128,7 @@
           <a:lstStyle/>
           <a:p>
             <a:pPr algn="ctr"/>
+            <a:endParaRPr/>
           </a:p>
         </p:txBody>
       </p:sp>
@@ -14610,6 +15172,7 @@
           <a:lstStyle/>
           <a:p>
             <a:pPr algn="ctr"/>
+            <a:endParaRPr/>
           </a:p>
         </p:txBody>
       </p:sp>
@@ -14731,6 +15294,7 @@
           <a:lstStyle/>
           <a:p>
             <a:pPr algn="ctr"/>
+            <a:endParaRPr/>
           </a:p>
         </p:txBody>
       </p:sp>
@@ -14774,6 +15338,7 @@
           <a:lstStyle/>
           <a:p>
             <a:pPr algn="ctr"/>
+            <a:endParaRPr/>
           </a:p>
         </p:txBody>
       </p:sp>
@@ -14817,6 +15382,7 @@
           <a:lstStyle/>
           <a:p>
             <a:pPr algn="ctr"/>
+            <a:endParaRPr/>
           </a:p>
         </p:txBody>
       </p:sp>
@@ -14905,7 +15471,7 @@
 </file>
 
 <file path=ppt/slides/slide9.xml><?xml version="1.0" encoding="utf-8"?>
-<p:sld xmlns:a="http://schemas.openxmlformats.org/drawingml/2006/main" xmlns:p="http://schemas.openxmlformats.org/presentationml/2006/main" xmlns:r="http://schemas.openxmlformats.org/officeDocument/2006/relationships">
+<p:sld xmlns:a="http://schemas.openxmlformats.org/drawingml/2006/main" xmlns:r="http://schemas.openxmlformats.org/officeDocument/2006/relationships" xmlns:p="http://schemas.openxmlformats.org/presentationml/2006/main">
   <p:cSld>
     <p:bg>
       <p:bgPr>
@@ -14921,7 +15487,14 @@
         <p:cNvGrpSpPr/>
         <p:nvPr/>
       </p:nvGrpSpPr>
-      <p:grpSpPr/>
+      <p:grpSpPr>
+        <a:xfrm>
+          <a:off x="0" y="0"/>
+          <a:ext cx="0" cy="0"/>
+          <a:chOff x="0" y="0"/>
+          <a:chExt cx="0" cy="0"/>
+        </a:xfrm>
+      </p:grpSpPr>
       <p:sp>
         <p:nvSpPr>
           <p:cNvPr id="2" name="TextBox 1"/>
@@ -14998,6 +15571,7 @@
           <a:lstStyle/>
           <a:p>
             <a:pPr algn="ctr"/>
+            <a:endParaRPr/>
           </a:p>
         </p:txBody>
       </p:sp>
@@ -15498,7 +16072,7 @@
                 </a:solidFill>
                 <a:latin typeface="Calibri"/>
               </a:rPr>
-              <a:t>Hosting gratuito incluso (GitHub Pages)</a:t>
+              <a:t>Pubblicazione online, hosting e configurazione dominio</a:t>
             </a:r>
           </a:p>
           <a:p>

</xml_diff>